<commit_message>
Wire forward buttons to the selection appendix in the standalone slides
Co-Authored-By: Claude Fable 5 <noreply@anthropic.com>
Claude-Session: https://claude.ai/code/session_01DNzQPDcr3zfLTraMHUHqUn
</commit_message>
<xml_diff>
--- a/report/data_cluster/selection_slides.pptx
+++ b/report/data_cluster/selection_slides.pptx
@@ -3140,7 +3140,7 @@
         </p:blipFill>
         <p:spPr>
           <a:xfrm>
-            <a:off x="1869141" y="1005840"/>
+            <a:off x="1869141" y="960120"/>
             <a:ext cx="8423237" cy="4937760"/>
           </a:xfrm>
           <a:prstGeom prst="rect">
@@ -3156,7 +3156,7 @@
         </p:nvSpPr>
         <p:spPr>
           <a:xfrm>
-            <a:off x="822960" y="6126480"/>
+            <a:off x="822960" y="5961888"/>
             <a:ext cx="10789920" cy="457200"/>
           </a:xfrm>
           <a:prstGeom prst="rect">
@@ -3178,6 +3178,70 @@
                 <a:latin typeface="Garamond"/>
               </a:rPr>
               <a:t>Probit average marginal effects, reduced controls in both periods. Age enters as a quadratic and is therefore not shown. Baseline rates: 7.9% (1997–2017) and 7.3% (2018–2024).</a:t>
+            </a:r>
+          </a:p>
+        </p:txBody>
+      </p:sp>
+      <p:sp>
+        <p:nvSpPr>
+          <p:cNvPr id="5" name="Rounded Rectangle 4">
+            <a:hlinkClick action="ppaction://hlinksldjump" r:id="rId3"/>
+          </p:cNvPr>
+          <p:cNvSpPr/>
+          <p:nvPr/>
+        </p:nvSpPr>
+        <p:spPr>
+          <a:xfrm>
+            <a:off x="822960" y="6327648"/>
+            <a:ext cx="2071116" cy="365760"/>
+          </a:xfrm>
+          <a:prstGeom prst="roundRect">
+            <a:avLst/>
+          </a:prstGeom>
+          <a:solidFill>
+            <a:srgbClr val="BED3EE"/>
+          </a:solidFill>
+          <a:ln>
+            <a:noFill/>
+          </a:ln>
+          <a:effectLst/>
+        </p:spPr>
+        <p:style>
+          <a:lnRef idx="1">
+            <a:schemeClr val="accent1"/>
+          </a:lnRef>
+          <a:fillRef idx="3">
+            <a:schemeClr val="accent1"/>
+          </a:fillRef>
+          <a:effectRef idx="2">
+            <a:schemeClr val="accent1"/>
+          </a:effectRef>
+          <a:fontRef idx="minor">
+            <a:schemeClr val="lt1"/>
+          </a:fontRef>
+        </p:style>
+        <p:txBody>
+          <a:bodyPr rtlCol="0" anchor="ctr" wrap="none" lIns="36576" rIns="36576" tIns="0" bIns="0"/>
+          <a:lstStyle/>
+          <a:p>
+            <a:pPr algn="ctr"/>
+            <a:r>
+              <a:rPr sz="1800" b="1">
+                <a:solidFill>
+                  <a:srgbClr val="102D5E"/>
+                </a:solidFill>
+                <a:latin typeface="Garamond"/>
+              </a:rPr>
+              <a:t>☞ </a:t>
+            </a:r>
+            <a:r>
+              <a:rPr sz="1400">
+                <a:solidFill>
+                  <a:srgbClr val="102D5E"/>
+                </a:solidFill>
+                <a:latin typeface="Garamond"/>
+              </a:rPr>
+              <a:t>selection table</a:t>
             </a:r>
           </a:p>
         </p:txBody>
@@ -3250,7 +3314,7 @@
         </p:blipFill>
         <p:spPr>
           <a:xfrm>
-            <a:off x="1741516" y="1005840"/>
+            <a:off x="1741516" y="960120"/>
             <a:ext cx="8678487" cy="4937760"/>
           </a:xfrm>
           <a:prstGeom prst="rect">
@@ -3266,7 +3330,7 @@
         </p:nvSpPr>
         <p:spPr>
           <a:xfrm>
-            <a:off x="822960" y="6126480"/>
+            <a:off x="822960" y="5961888"/>
             <a:ext cx="10789920" cy="457200"/>
           </a:xfrm>
           <a:prstGeom prst="rect">
@@ -3288,6 +3352,70 @@
                 <a:latin typeface="Garamond"/>
               </a:rPr>
               <a:t>Probit average marginal effects, surveys 1998–2025, N = 84,146. Age enters as a quadratic and is therefore not shown.</a:t>
+            </a:r>
+          </a:p>
+        </p:txBody>
+      </p:sp>
+      <p:sp>
+        <p:nvSpPr>
+          <p:cNvPr id="5" name="Rounded Rectangle 4">
+            <a:hlinkClick action="ppaction://hlinksldjump" r:id="rId3"/>
+          </p:cNvPr>
+          <p:cNvSpPr/>
+          <p:nvPr/>
+        </p:nvSpPr>
+        <p:spPr>
+          <a:xfrm>
+            <a:off x="822960" y="6327648"/>
+            <a:ext cx="2071116" cy="365760"/>
+          </a:xfrm>
+          <a:prstGeom prst="roundRect">
+            <a:avLst/>
+          </a:prstGeom>
+          <a:solidFill>
+            <a:srgbClr val="BED3EE"/>
+          </a:solidFill>
+          <a:ln>
+            <a:noFill/>
+          </a:ln>
+          <a:effectLst/>
+        </p:spPr>
+        <p:style>
+          <a:lnRef idx="1">
+            <a:schemeClr val="accent1"/>
+          </a:lnRef>
+          <a:fillRef idx="3">
+            <a:schemeClr val="accent1"/>
+          </a:fillRef>
+          <a:effectRef idx="2">
+            <a:schemeClr val="accent1"/>
+          </a:effectRef>
+          <a:fontRef idx="minor">
+            <a:schemeClr val="lt1"/>
+          </a:fontRef>
+        </p:style>
+        <p:txBody>
+          <a:bodyPr rtlCol="0" anchor="ctr" wrap="none" lIns="36576" rIns="36576" tIns="0" bIns="0"/>
+          <a:lstStyle/>
+          <a:p>
+            <a:pPr algn="ctr"/>
+            <a:r>
+              <a:rPr sz="1800" b="1">
+                <a:solidFill>
+                  <a:srgbClr val="102D5E"/>
+                </a:solidFill>
+                <a:latin typeface="Garamond"/>
+              </a:rPr>
+              <a:t>☞ </a:t>
+            </a:r>
+            <a:r>
+              <a:rPr sz="1400">
+                <a:solidFill>
+                  <a:srgbClr val="102D5E"/>
+                </a:solidFill>
+                <a:latin typeface="Garamond"/>
+              </a:rPr>
+              <a:t>selection table</a:t>
             </a:r>
           </a:p>
         </p:txBody>

</xml_diff>

<commit_message>
Selection slides: notes state that health and disability are controlled
Co-Authored-By: Claude Opus 5.5 <noreply@anthropic.com>
Claude-Session: https://claude.ai/code/session_01DNzQPDcr3zfLTraMHUHqUn
</commit_message>
<xml_diff>
--- a/report/data_cluster/selection_slides.pptx
+++ b/report/data_cluster/selection_slides.pptx
@@ -3177,7 +3177,7 @@
                 </a:solidFill>
                 <a:latin typeface="Garamond"/>
               </a:rPr>
-              <a:t>Probit average marginal effects, reduced controls in both periods. Age enters as a quadratic and is therefore not shown. Baseline rates: 7.9% (1997–2017) and 7.3% (2018–2024).</a:t>
+              <a:t>Probit average marginal effects with the controls available in every year, health and disability included. Age enters as a quadratic and is not shown. Baseline rates: 7.9% (1997–2017) and 7.3% (2018–2024).</a:t>
             </a:r>
           </a:p>
         </p:txBody>
@@ -3351,7 +3351,7 @@
                 </a:solidFill>
                 <a:latin typeface="Garamond"/>
               </a:rPr>
-              <a:t>Probit average marginal effects, surveys 1998–2025, N = 84,146. Age enters as a quadratic and is therefore not shown.</a:t>
+              <a:t>Probit average marginal effects, surveys 1998–2025, N = 84,146, health and disability included. Age enters as a quadratic and is not shown.</a:t>
             </a:r>
           </a:p>
         </p:txBody>

</xml_diff>